<commit_message>
docs: anadir Figura 5 de streaming en word y pptx
</commit_message>
<xml_diff>
--- a/presentacion/Sustentación Tarea 3 Big Data UNAD.pptx
+++ b/presentacion/Sustentación Tarea 3 Big Data UNAD.pptx
@@ -7630,18 +7630,7 @@
             <a:spAutoFit/>
           </a:bodyPr>
           <a:lstStyle/>
-          <a:p>
-            <a:pPr algn="l"/>
-            <a:r>
-              <a:rPr b="1" sz="1050" i="0" u="none">
-                <a:solidFill>
-                  <a:srgbClr val="D87014"/>
-                </a:solidFill>
-                <a:latin typeface="DM Sans"/>
-              </a:rPr>
-              <a:t>OBSERVABILIDAD Y TELEMETRÍA DE CLÚSTER</a:t>
-            </a:r>
-          </a:p>
+          <a:p/>
         </p:txBody>
       </p:sp>
       <p:sp>
@@ -7665,18 +7654,7 @@
             <a:spAutoFit/>
           </a:bodyPr>
           <a:lstStyle/>
-          <a:p>
-            <a:pPr algn="l"/>
-            <a:r>
-              <a:rPr b="1" sz="1800" i="0" u="none">
-                <a:solidFill>
-                  <a:srgbClr val="FFFFFF"/>
-                </a:solidFill>
-                <a:latin typeface="Space Grotesk"/>
-              </a:rPr>
-              <a:t>Auditoría en Tiempo Real mediante Spark Web UI (Puerto 4040)</a:t>
-            </a:r>
-          </a:p>
+          <a:p/>
         </p:txBody>
       </p:sp>
       <p:sp>
@@ -7700,18 +7678,7 @@
             <a:spAutoFit/>
           </a:bodyPr>
           <a:lstStyle/>
-          <a:p>
-            <a:pPr algn="l"/>
-            <a:r>
-              <a:rPr b="0" sz="1350" i="0" u="none">
-                <a:solidFill>
-                  <a:srgbClr val="CBD5E1"/>
-                </a:solidFill>
-                <a:latin typeface="DM Sans"/>
-              </a:rPr>
-              <a:t>Inspección de Jobs activos, DAG de Stages por micro-batch, entorno y consumo RAM en Executors.</a:t>
-            </a:r>
-          </a:p>
+          <a:p/>
         </p:txBody>
       </p:sp>
       <p:sp>
@@ -7735,18 +7702,7 @@
             <a:spAutoFit/>
           </a:bodyPr>
           <a:lstStyle/>
-          <a:p>
-            <a:pPr algn="r"/>
-            <a:r>
-              <a:rPr b="1" sz="2700" i="0" u="none">
-                <a:solidFill>
-                  <a:srgbClr val="D87014"/>
-                </a:solidFill>
-                <a:latin typeface="DM Sans"/>
-              </a:rPr>
-              <a:t>:4040</a:t>
-            </a:r>
-          </a:p>
+          <a:p/>
         </p:txBody>
       </p:sp>
       <p:sp>
@@ -7770,20 +7726,33 @@
             <a:spAutoFit/>
           </a:bodyPr>
           <a:lstStyle/>
-          <a:p>
-            <a:pPr algn="r"/>
-            <a:r>
-              <a:rPr b="0" sz="1200" i="0" u="none">
-                <a:solidFill>
-                  <a:srgbClr val="FFFFFF"/>
-                </a:solidFill>
-                <a:latin typeface="DM Sans"/>
-              </a:rPr>
-              <a:t>Spark UI</a:t>
-            </a:r>
-          </a:p>
-        </p:txBody>
-      </p:sp>
+          <a:p/>
+        </p:txBody>
+      </p:sp>
+      <p:pic>
+        <p:nvPicPr>
+          <p:cNvPr id="22" name="Picture 21" descr="figura5_streaming_kafka_spark.png"/>
+          <p:cNvPicPr>
+            <a:picLocks noChangeAspect="1"/>
+          </p:cNvPicPr>
+          <p:nvPr/>
+        </p:nvPicPr>
+        <p:blipFill>
+          <a:blip r:embed="rId2"/>
+          <a:stretch>
+            <a:fillRect/>
+          </a:stretch>
+        </p:blipFill>
+        <p:spPr>
+          <a:xfrm>
+            <a:off x="612648" y="3291840"/>
+            <a:ext cx="10972800" cy="3291840"/>
+          </a:xfrm>
+          <a:prstGeom prst="rect">
+            <a:avLst/>
+          </a:prstGeom>
+        </p:spPr>
+      </p:pic>
     </p:spTree>
   </p:cSld>
   <p:clrMapOvr>

</xml_diff>

<commit_message>
Add final YouTube video and Google Slides links to report, presentation, and README
</commit_message>
<xml_diff>
--- a/presentacion/Sustentación Tarea 3 Big Data UNAD.pptx
+++ b/presentacion/Sustentación Tarea 3 Big Data UNAD.pptx
@@ -4256,13 +4256,13 @@
           </a:p>
           <a:p>
             <a:r>
-              <a:rPr sz="1300" b="1">
+              <a:rPr sz="1400" b="1">
                 <a:solidFill>
                   <a:srgbClr val="005691"/>
                 </a:solidFill>
                 <a:latin typeface="Segoe UI"/>
               </a:rPr>
-              <a:t>[Pegar aquí el enlace de YouTube / Loom / Drive tras finalizar la grabación]</a:t>
+              <a:t>https://youtu.be/lX0_CDMhhbg</a:t>
             </a:r>
           </a:p>
         </p:txBody>

</xml_diff>

<commit_message>
Update video link to Google Drive across report, presentation, and README
</commit_message>
<xml_diff>
--- a/presentacion/Sustentación Tarea 3 Big Data UNAD.pptx
+++ b/presentacion/Sustentación Tarea 3 Big Data UNAD.pptx
@@ -4256,13 +4256,13 @@
           </a:p>
           <a:p>
             <a:r>
-              <a:rPr sz="1400" b="1">
+              <a:rPr sz="1150" b="1">
                 <a:solidFill>
                   <a:srgbClr val="005691"/>
                 </a:solidFill>
                 <a:latin typeface="Segoe UI"/>
               </a:rPr>
-              <a:t>https://youtu.be/lX0_CDMhhbg</a:t>
+              <a:t>https://drive.google.com/file/d/1W-Wxs7EDEc5xnfTqt0UkKGFZ4y3kINNL/view?usp=sharing</a:t>
             </a:r>
           </a:p>
         </p:txBody>

</xml_diff>